<commit_message>
Neuron morphology with synapses.
</commit_message>
<xml_diff>
--- a/temporal-interference/annotations.pptx
+++ b/temporal-interference/annotations.pptx
@@ -6,6 +6,7 @@
   </p:sldMasterIdLst>
   <p:sldIdLst>
     <p:sldId id="256" r:id="rId2"/>
+    <p:sldId id="257" r:id="rId3"/>
   </p:sldIdLst>
   <p:sldSz cx="12192000" cy="6858000"/>
   <p:notesSz cx="6858000" cy="9144000"/>
@@ -104,6 +105,11 @@
       </a:defRPr>
     </a:lvl9pPr>
   </p:defaultTextStyle>
+  <p:extLst>
+    <p:ext uri="{EFAFB233-063F-42B5-8137-9DF3F51BA10A}">
+      <p15:sldGuideLst xmlns:p15="http://schemas.microsoft.com/office/powerpoint/2012/main"/>
+    </p:ext>
+  </p:extLst>
 </p:presentation>
 </file>
 
@@ -3736,6 +3742,416 @@
 </p:sld>
 </file>
 
+<file path=ppt/slides/slide2.xml><?xml version="1.0" encoding="utf-8"?>
+<p:sld xmlns:a="http://schemas.openxmlformats.org/drawingml/2006/main" xmlns:r="http://schemas.openxmlformats.org/officeDocument/2006/relationships" xmlns:p="http://schemas.openxmlformats.org/presentationml/2006/main">
+  <p:cSld>
+    <p:spTree>
+      <p:nvGrpSpPr>
+        <p:cNvPr id="1" name=""/>
+        <p:cNvGrpSpPr/>
+        <p:nvPr/>
+      </p:nvGrpSpPr>
+      <p:grpSpPr>
+        <a:xfrm>
+          <a:off x="0" y="0"/>
+          <a:ext cx="0" cy="0"/>
+          <a:chOff x="0" y="0"/>
+          <a:chExt cx="0" cy="0"/>
+        </a:xfrm>
+      </p:grpSpPr>
+      <p:grpSp>
+        <p:nvGrpSpPr>
+          <p:cNvPr id="2" name="Group 1">
+            <a:extLst>
+              <a:ext uri="{FF2B5EF4-FFF2-40B4-BE49-F238E27FC236}">
+                <a16:creationId xmlns:a16="http://schemas.microsoft.com/office/drawing/2014/main" id="{5C6693A6-0C92-A816-1A82-01DB67AFEF23}"/>
+              </a:ext>
+            </a:extLst>
+          </p:cNvPr>
+          <p:cNvGrpSpPr/>
+          <p:nvPr/>
+        </p:nvGrpSpPr>
+        <p:grpSpPr>
+          <a:xfrm>
+            <a:off x="0" y="0"/>
+            <a:ext cx="12192000" cy="6858000"/>
+            <a:chOff x="0" y="0"/>
+            <a:chExt cx="12192000" cy="6858000"/>
+          </a:xfrm>
+        </p:grpSpPr>
+        <p:pic>
+          <p:nvPicPr>
+            <p:cNvPr id="5" name="Picture 4">
+              <a:extLst>
+                <a:ext uri="{FF2B5EF4-FFF2-40B4-BE49-F238E27FC236}">
+                  <a16:creationId xmlns:a16="http://schemas.microsoft.com/office/drawing/2014/main" id="{FB5FAB63-A243-83B6-9FD1-A61A192049F1}"/>
+                </a:ext>
+              </a:extLst>
+            </p:cNvPr>
+            <p:cNvPicPr>
+              <a:picLocks noChangeAspect="1"/>
+            </p:cNvPicPr>
+            <p:nvPr/>
+          </p:nvPicPr>
+          <p:blipFill>
+            <a:blip r:embed="rId2"/>
+            <a:srcRect/>
+            <a:stretch/>
+          </p:blipFill>
+          <p:spPr>
+            <a:xfrm>
+              <a:off x="0" y="0"/>
+              <a:ext cx="12192000" cy="6858000"/>
+            </a:xfrm>
+            <a:prstGeom prst="rect">
+              <a:avLst/>
+            </a:prstGeom>
+          </p:spPr>
+        </p:pic>
+        <p:sp>
+          <p:nvSpPr>
+            <p:cNvPr id="6" name="TextBox 5">
+              <a:extLst>
+                <a:ext uri="{FF2B5EF4-FFF2-40B4-BE49-F238E27FC236}">
+                  <a16:creationId xmlns:a16="http://schemas.microsoft.com/office/drawing/2014/main" id="{3E88CAA3-C73D-A07A-60CE-3C28EE278FAB}"/>
+                </a:ext>
+              </a:extLst>
+            </p:cNvPr>
+            <p:cNvSpPr txBox="1"/>
+            <p:nvPr/>
+          </p:nvSpPr>
+          <p:spPr>
+            <a:xfrm>
+              <a:off x="4560124" y="2448790"/>
+              <a:ext cx="524503" cy="276999"/>
+            </a:xfrm>
+            <a:prstGeom prst="rect">
+              <a:avLst/>
+            </a:prstGeom>
+            <a:noFill/>
+          </p:spPr>
+          <p:txBody>
+            <a:bodyPr wrap="none" rtlCol="0">
+              <a:spAutoFit/>
+            </a:bodyPr>
+            <a:lstStyle/>
+            <a:p>
+              <a:r>
+                <a:rPr lang="en-LT" sz="1200" dirty="0"/>
+                <a:t>soma</a:t>
+              </a:r>
+            </a:p>
+          </p:txBody>
+        </p:sp>
+        <p:sp>
+          <p:nvSpPr>
+            <p:cNvPr id="7" name="TextBox 6">
+              <a:extLst>
+                <a:ext uri="{FF2B5EF4-FFF2-40B4-BE49-F238E27FC236}">
+                  <a16:creationId xmlns:a16="http://schemas.microsoft.com/office/drawing/2014/main" id="{8DB5D642-5A65-976D-C074-896CE79A32A9}"/>
+                </a:ext>
+              </a:extLst>
+            </p:cNvPr>
+            <p:cNvSpPr txBox="1"/>
+            <p:nvPr/>
+          </p:nvSpPr>
+          <p:spPr>
+            <a:xfrm>
+              <a:off x="3411391" y="4466273"/>
+              <a:ext cx="1136786" cy="276999"/>
+            </a:xfrm>
+            <a:prstGeom prst="rect">
+              <a:avLst/>
+            </a:prstGeom>
+            <a:noFill/>
+          </p:spPr>
+          <p:txBody>
+            <a:bodyPr wrap="none" rtlCol="0">
+              <a:spAutoFit/>
+            </a:bodyPr>
+            <a:lstStyle/>
+            <a:p>
+              <a:r>
+                <a:rPr lang="en-LT" sz="1200" dirty="0"/>
+                <a:t>basal dendrites</a:t>
+              </a:r>
+            </a:p>
+          </p:txBody>
+        </p:sp>
+        <p:sp>
+          <p:nvSpPr>
+            <p:cNvPr id="8" name="TextBox 7">
+              <a:extLst>
+                <a:ext uri="{FF2B5EF4-FFF2-40B4-BE49-F238E27FC236}">
+                  <a16:creationId xmlns:a16="http://schemas.microsoft.com/office/drawing/2014/main" id="{C8765494-CEEF-3A20-524A-AA34E9A4C12B}"/>
+                </a:ext>
+              </a:extLst>
+            </p:cNvPr>
+            <p:cNvSpPr txBox="1"/>
+            <p:nvPr/>
+          </p:nvSpPr>
+          <p:spPr>
+            <a:xfrm>
+              <a:off x="6738843" y="4466273"/>
+              <a:ext cx="1175578" cy="276999"/>
+            </a:xfrm>
+            <a:prstGeom prst="rect">
+              <a:avLst/>
+            </a:prstGeom>
+            <a:noFill/>
+          </p:spPr>
+          <p:txBody>
+            <a:bodyPr wrap="none" rtlCol="0">
+              <a:spAutoFit/>
+            </a:bodyPr>
+            <a:lstStyle/>
+            <a:p>
+              <a:r>
+                <a:rPr lang="en-GB" sz="1200" dirty="0"/>
+                <a:t>a</a:t>
+              </a:r>
+              <a:r>
+                <a:rPr lang="en-LT" sz="1200" dirty="0"/>
+                <a:t>pical dendrites</a:t>
+              </a:r>
+            </a:p>
+          </p:txBody>
+        </p:sp>
+        <p:sp>
+          <p:nvSpPr>
+            <p:cNvPr id="9" name="TextBox 8">
+              <a:extLst>
+                <a:ext uri="{FF2B5EF4-FFF2-40B4-BE49-F238E27FC236}">
+                  <a16:creationId xmlns:a16="http://schemas.microsoft.com/office/drawing/2014/main" id="{E9086BD9-32CE-0A46-786A-05C45B4F1E5E}"/>
+                </a:ext>
+              </a:extLst>
+            </p:cNvPr>
+            <p:cNvSpPr txBox="1"/>
+            <p:nvPr/>
+          </p:nvSpPr>
+          <p:spPr>
+            <a:xfrm>
+              <a:off x="5084627" y="2448790"/>
+              <a:ext cx="482120" cy="276999"/>
+            </a:xfrm>
+            <a:prstGeom prst="rect">
+              <a:avLst/>
+            </a:prstGeom>
+            <a:noFill/>
+          </p:spPr>
+          <p:txBody>
+            <a:bodyPr wrap="none" rtlCol="0">
+              <a:spAutoFit/>
+            </a:bodyPr>
+            <a:lstStyle/>
+            <a:p>
+              <a:r>
+                <a:rPr lang="en-LT" sz="1200" dirty="0"/>
+                <a:t>axon</a:t>
+              </a:r>
+            </a:p>
+          </p:txBody>
+        </p:sp>
+        <p:sp>
+          <p:nvSpPr>
+            <p:cNvPr id="10" name="Left Brace 9">
+              <a:extLst>
+                <a:ext uri="{FF2B5EF4-FFF2-40B4-BE49-F238E27FC236}">
+                  <a16:creationId xmlns:a16="http://schemas.microsoft.com/office/drawing/2014/main" id="{1298F20E-A93F-C80E-9C47-FB8666100104}"/>
+                </a:ext>
+              </a:extLst>
+            </p:cNvPr>
+            <p:cNvSpPr/>
+            <p:nvPr/>
+          </p:nvSpPr>
+          <p:spPr>
+            <a:xfrm rot="16200000">
+              <a:off x="3901203" y="3446858"/>
+              <a:ext cx="157163" cy="1881666"/>
+            </a:xfrm>
+            <a:prstGeom prst="leftBrace">
+              <a:avLst/>
+            </a:prstGeom>
+            <a:ln w="9525">
+              <a:solidFill>
+                <a:srgbClr val="C00000"/>
+              </a:solidFill>
+            </a:ln>
+          </p:spPr>
+          <p:style>
+            <a:lnRef idx="1">
+              <a:schemeClr val="dk1"/>
+            </a:lnRef>
+            <a:fillRef idx="0">
+              <a:schemeClr val="dk1"/>
+            </a:fillRef>
+            <a:effectRef idx="0">
+              <a:schemeClr val="dk1"/>
+            </a:effectRef>
+            <a:fontRef idx="minor">
+              <a:schemeClr val="tx1"/>
+            </a:fontRef>
+          </p:style>
+          <p:txBody>
+            <a:bodyPr rtlCol="0" anchor="ctr"/>
+            <a:lstStyle/>
+            <a:p>
+              <a:pPr algn="ctr"/>
+              <a:endParaRPr lang="en-LT"/>
+            </a:p>
+          </p:txBody>
+        </p:sp>
+        <p:sp>
+          <p:nvSpPr>
+            <p:cNvPr id="11" name="Left Brace 10">
+              <a:extLst>
+                <a:ext uri="{FF2B5EF4-FFF2-40B4-BE49-F238E27FC236}">
+                  <a16:creationId xmlns:a16="http://schemas.microsoft.com/office/drawing/2014/main" id="{5E9CCDF8-4A24-A977-911B-5AF3C41B9792}"/>
+                </a:ext>
+              </a:extLst>
+            </p:cNvPr>
+            <p:cNvSpPr/>
+            <p:nvPr/>
+          </p:nvSpPr>
+          <p:spPr>
+            <a:xfrm rot="16200000">
+              <a:off x="7248051" y="2004535"/>
+              <a:ext cx="157163" cy="4766311"/>
+            </a:xfrm>
+            <a:prstGeom prst="leftBrace">
+              <a:avLst/>
+            </a:prstGeom>
+            <a:ln w="9525">
+              <a:solidFill>
+                <a:srgbClr val="C00000"/>
+              </a:solidFill>
+            </a:ln>
+          </p:spPr>
+          <p:style>
+            <a:lnRef idx="1">
+              <a:schemeClr val="dk1"/>
+            </a:lnRef>
+            <a:fillRef idx="0">
+              <a:schemeClr val="dk1"/>
+            </a:fillRef>
+            <a:effectRef idx="0">
+              <a:schemeClr val="dk1"/>
+            </a:effectRef>
+            <a:fontRef idx="minor">
+              <a:schemeClr val="tx1"/>
+            </a:fontRef>
+          </p:style>
+          <p:txBody>
+            <a:bodyPr rtlCol="0" anchor="ctr"/>
+            <a:lstStyle/>
+            <a:p>
+              <a:pPr algn="ctr"/>
+              <a:endParaRPr lang="en-LT"/>
+            </a:p>
+          </p:txBody>
+        </p:sp>
+        <p:cxnSp>
+          <p:nvCxnSpPr>
+            <p:cNvPr id="13" name="Straight Connector 12">
+              <a:extLst>
+                <a:ext uri="{FF2B5EF4-FFF2-40B4-BE49-F238E27FC236}">
+                  <a16:creationId xmlns:a16="http://schemas.microsoft.com/office/drawing/2014/main" id="{4B742BE8-E51B-AB96-79EA-5011C866397C}"/>
+                </a:ext>
+              </a:extLst>
+            </p:cNvPr>
+            <p:cNvCxnSpPr>
+              <a:cxnSpLocks/>
+              <a:stCxn id="6" idx="2"/>
+            </p:cNvCxnSpPr>
+            <p:nvPr/>
+          </p:nvCxnSpPr>
+          <p:spPr>
+            <a:xfrm>
+              <a:off x="4822376" y="2725789"/>
+              <a:ext cx="103005" cy="960299"/>
+            </a:xfrm>
+            <a:prstGeom prst="line">
+              <a:avLst/>
+            </a:prstGeom>
+            <a:ln w="9525">
+              <a:solidFill>
+                <a:srgbClr val="C00000"/>
+              </a:solidFill>
+            </a:ln>
+          </p:spPr>
+          <p:style>
+            <a:lnRef idx="1">
+              <a:schemeClr val="accent2"/>
+            </a:lnRef>
+            <a:fillRef idx="0">
+              <a:schemeClr val="accent2"/>
+            </a:fillRef>
+            <a:effectRef idx="0">
+              <a:schemeClr val="accent2"/>
+            </a:effectRef>
+            <a:fontRef idx="minor">
+              <a:schemeClr val="tx1"/>
+            </a:fontRef>
+          </p:style>
+        </p:cxnSp>
+        <p:cxnSp>
+          <p:nvCxnSpPr>
+            <p:cNvPr id="14" name="Straight Connector 13">
+              <a:extLst>
+                <a:ext uri="{FF2B5EF4-FFF2-40B4-BE49-F238E27FC236}">
+                  <a16:creationId xmlns:a16="http://schemas.microsoft.com/office/drawing/2014/main" id="{6D02D5EB-DABA-A17A-F81D-B2CB5E24EFD9}"/>
+                </a:ext>
+              </a:extLst>
+            </p:cNvPr>
+            <p:cNvCxnSpPr>
+              <a:cxnSpLocks/>
+              <a:stCxn id="9" idx="2"/>
+            </p:cNvCxnSpPr>
+            <p:nvPr/>
+          </p:nvCxnSpPr>
+          <p:spPr>
+            <a:xfrm flipH="1">
+              <a:off x="5264153" y="2725789"/>
+              <a:ext cx="61534" cy="713331"/>
+            </a:xfrm>
+            <a:prstGeom prst="line">
+              <a:avLst/>
+            </a:prstGeom>
+            <a:ln w="9525">
+              <a:solidFill>
+                <a:srgbClr val="C00000"/>
+              </a:solidFill>
+            </a:ln>
+          </p:spPr>
+          <p:style>
+            <a:lnRef idx="1">
+              <a:schemeClr val="accent2"/>
+            </a:lnRef>
+            <a:fillRef idx="0">
+              <a:schemeClr val="accent2"/>
+            </a:fillRef>
+            <a:effectRef idx="0">
+              <a:schemeClr val="accent2"/>
+            </a:effectRef>
+            <a:fontRef idx="minor">
+              <a:schemeClr val="tx1"/>
+            </a:fontRef>
+          </p:style>
+        </p:cxnSp>
+      </p:grpSp>
+    </p:spTree>
+    <p:extLst>
+      <p:ext uri="{BB962C8B-B14F-4D97-AF65-F5344CB8AC3E}">
+        <p14:creationId xmlns:p14="http://schemas.microsoft.com/office/powerpoint/2010/main" val="2066664187"/>
+      </p:ext>
+    </p:extLst>
+  </p:cSld>
+  <p:clrMapOvr>
+    <a:masterClrMapping/>
+  </p:clrMapOvr>
+</p:sld>
+</file>
+
 <file path=ppt/theme/theme1.xml><?xml version="1.0" encoding="utf-8"?>
 <a:theme xmlns:a="http://schemas.openxmlformats.org/drawingml/2006/main" name="Office Theme">
   <a:themeElements>

</xml_diff>